<commit_message>
Make Article 34 fingerprints heart-shaped and place them on the red lines
Co-Authored-By: Claude Opus 5.5 <noreply@anthropic.com>
Claude-Session: https://claude.ai/code/session_01WRutf32KVp8QwfQ7GUQYog
</commit_message>
<xml_diff>
--- a/slide-article-34/السعودية-بصمة-دفاع-المادة-34.pptx
+++ b/slide-article-34/السعودية-بصمة-دفاع-المادة-34.pptx
@@ -502,7 +502,7 @@
           <a:lstStyle/>
           <a:p>
             <a:r>
-              <a:t>اضغطي (نقرة أو مسافة أو السهم الأيمن) لإظهار البصمات واحدة تلو الأخرى، بالتناوب بين اليمين واليسار حتى تكتمل البصمات الأربع والعشرون. لتعديل الاسمين انقري داخل المربعين أسفل الشريحة.</a:t>
+              <a:t>اضغطي (نقرة أو مسافة أو السهم الأيمن) لإظهار البصمات واحدة تلو الأخرى، على الخطين الأحمرين بالتناوب بين اليمين واليسار حتى تكتمل البصمات الأربع والعشرون. لتعديل الاسمين انقري داخل المربعين أسفل الشريحة.</a:t>
             </a:r>
           </a:p>
         </p:txBody>
@@ -3524,7 +3524,7 @@
         </p:nvCxnSpPr>
         <p:spPr>
           <a:xfrm>
-            <a:off x="502920" y="3246120"/>
+            <a:off x="502920" y="2788920"/>
             <a:ext cx="11183112" cy="0"/>
           </a:xfrm>
           <a:prstGeom prst="line">
@@ -3559,7 +3559,7 @@
         </p:nvCxnSpPr>
         <p:spPr>
           <a:xfrm>
-            <a:off x="502920" y="3611880"/>
+            <a:off x="502920" y="3977639"/>
             <a:ext cx="11183112" cy="0"/>
           </a:xfrm>
           <a:prstGeom prst="line">
@@ -3933,7 +3933,7 @@
       </p:sp>
       <p:pic>
         <p:nvPicPr>
-          <p:cNvPr id="12" name="بصمة 05" descr="fp0.png"/>
+          <p:cNvPr id="12" name="بصمة 01" descr="fp0.png"/>
           <p:cNvPicPr>
             <a:picLocks noChangeAspect="1"/>
           </p:cNvPicPr>
@@ -3946,9 +3946,9 @@
           </a:stretch>
         </p:blipFill>
         <p:spPr>
-          <a:xfrm rot="20760000">
-            <a:off x="11018520" y="1572768"/>
-            <a:ext cx="777240" cy="777240"/>
+          <a:xfrm rot="21240000">
+            <a:off x="11185855" y="2514600"/>
+            <a:ext cx="548640" cy="548640"/>
           </a:xfrm>
           <a:prstGeom prst="rect">
             <a:avLst/>
@@ -3970,9 +3970,9 @@
           </a:stretch>
         </p:blipFill>
         <p:spPr>
-          <a:xfrm rot="480000">
-            <a:off x="10012680" y="1773936"/>
-            <a:ext cx="777240" cy="777240"/>
+          <a:xfrm rot="240000">
+            <a:off x="10600639" y="2514600"/>
+            <a:ext cx="548640" cy="548640"/>
           </a:xfrm>
           <a:prstGeom prst="rect">
             <a:avLst/>
@@ -3981,7 +3981,415 @@
       </p:pic>
       <p:pic>
         <p:nvPicPr>
-          <p:cNvPr id="14" name="بصمة 01" descr="fp2.png"/>
+          <p:cNvPr id="14" name="بصمة 05" descr="fp2.png"/>
+          <p:cNvPicPr>
+            <a:picLocks noChangeAspect="1"/>
+          </p:cNvPicPr>
+          <p:nvPr/>
+        </p:nvPicPr>
+        <p:blipFill>
+          <a:blip r:embed="rId7"/>
+          <a:stretch>
+            <a:fillRect/>
+          </a:stretch>
+        </p:blipFill>
+        <p:spPr>
+          <a:xfrm rot="21420000">
+            <a:off x="10015423" y="2514600"/>
+            <a:ext cx="548640" cy="548640"/>
+          </a:xfrm>
+          <a:prstGeom prst="rect">
+            <a:avLst/>
+          </a:prstGeom>
+        </p:spPr>
+      </p:pic>
+      <p:pic>
+        <p:nvPicPr>
+          <p:cNvPr id="15" name="بصمة 07" descr="fp3.png"/>
+          <p:cNvPicPr>
+            <a:picLocks noChangeAspect="1"/>
+          </p:cNvPicPr>
+          <p:nvPr/>
+        </p:nvPicPr>
+        <p:blipFill>
+          <a:blip r:embed="rId8"/>
+          <a:stretch>
+            <a:fillRect/>
+          </a:stretch>
+        </p:blipFill>
+        <p:spPr>
+          <a:xfrm rot="360000">
+            <a:off x="9430207" y="2514600"/>
+            <a:ext cx="548640" cy="548640"/>
+          </a:xfrm>
+          <a:prstGeom prst="rect">
+            <a:avLst/>
+          </a:prstGeom>
+        </p:spPr>
+      </p:pic>
+      <p:pic>
+        <p:nvPicPr>
+          <p:cNvPr id="16" name="بصمة 09" descr="fp0.png"/>
+          <p:cNvPicPr>
+            <a:picLocks noChangeAspect="1"/>
+          </p:cNvPicPr>
+          <p:nvPr/>
+        </p:nvPicPr>
+        <p:blipFill>
+          <a:blip r:embed="rId5"/>
+          <a:stretch>
+            <a:fillRect/>
+          </a:stretch>
+        </p:blipFill>
+        <p:spPr>
+          <a:xfrm rot="21360000">
+            <a:off x="8844991" y="2514600"/>
+            <a:ext cx="548640" cy="548640"/>
+          </a:xfrm>
+          <a:prstGeom prst="rect">
+            <a:avLst/>
+          </a:prstGeom>
+        </p:spPr>
+      </p:pic>
+      <p:pic>
+        <p:nvPicPr>
+          <p:cNvPr id="17" name="بصمة 11" descr="fp1.png"/>
+          <p:cNvPicPr>
+            <a:picLocks noChangeAspect="1"/>
+          </p:cNvPicPr>
+          <p:nvPr/>
+        </p:nvPicPr>
+        <p:blipFill>
+          <a:blip r:embed="rId6"/>
+          <a:stretch>
+            <a:fillRect/>
+          </a:stretch>
+        </p:blipFill>
+        <p:spPr>
+          <a:xfrm rot="180000">
+            <a:off x="8259775" y="2514600"/>
+            <a:ext cx="548640" cy="548640"/>
+          </a:xfrm>
+          <a:prstGeom prst="rect">
+            <a:avLst/>
+          </a:prstGeom>
+        </p:spPr>
+      </p:pic>
+      <p:pic>
+        <p:nvPicPr>
+          <p:cNvPr id="18" name="بصمة 13" descr="fp1.png"/>
+          <p:cNvPicPr>
+            <a:picLocks noChangeAspect="1"/>
+          </p:cNvPicPr>
+          <p:nvPr/>
+        </p:nvPicPr>
+        <p:blipFill>
+          <a:blip r:embed="rId6"/>
+          <a:stretch>
+            <a:fillRect/>
+          </a:stretch>
+        </p:blipFill>
+        <p:spPr>
+          <a:xfrm rot="21240000">
+            <a:off x="11185855" y="3703320"/>
+            <a:ext cx="548640" cy="548640"/>
+          </a:xfrm>
+          <a:prstGeom prst="rect">
+            <a:avLst/>
+          </a:prstGeom>
+        </p:spPr>
+      </p:pic>
+      <p:pic>
+        <p:nvPicPr>
+          <p:cNvPr id="19" name="بصمة 15" descr="fp2.png"/>
+          <p:cNvPicPr>
+            <a:picLocks noChangeAspect="1"/>
+          </p:cNvPicPr>
+          <p:nvPr/>
+        </p:nvPicPr>
+        <p:blipFill>
+          <a:blip r:embed="rId7"/>
+          <a:stretch>
+            <a:fillRect/>
+          </a:stretch>
+        </p:blipFill>
+        <p:spPr>
+          <a:xfrm rot="240000">
+            <a:off x="10600639" y="3703320"/>
+            <a:ext cx="548640" cy="548640"/>
+          </a:xfrm>
+          <a:prstGeom prst="rect">
+            <a:avLst/>
+          </a:prstGeom>
+        </p:spPr>
+      </p:pic>
+      <p:pic>
+        <p:nvPicPr>
+          <p:cNvPr id="20" name="بصمة 17" descr="fp3.png"/>
+          <p:cNvPicPr>
+            <a:picLocks noChangeAspect="1"/>
+          </p:cNvPicPr>
+          <p:nvPr/>
+        </p:nvPicPr>
+        <p:blipFill>
+          <a:blip r:embed="rId8"/>
+          <a:stretch>
+            <a:fillRect/>
+          </a:stretch>
+        </p:blipFill>
+        <p:spPr>
+          <a:xfrm rot="21420000">
+            <a:off x="10015423" y="3703320"/>
+            <a:ext cx="548640" cy="548640"/>
+          </a:xfrm>
+          <a:prstGeom prst="rect">
+            <a:avLst/>
+          </a:prstGeom>
+        </p:spPr>
+      </p:pic>
+      <p:pic>
+        <p:nvPicPr>
+          <p:cNvPr id="21" name="بصمة 19" descr="fp0.png"/>
+          <p:cNvPicPr>
+            <a:picLocks noChangeAspect="1"/>
+          </p:cNvPicPr>
+          <p:nvPr/>
+        </p:nvPicPr>
+        <p:blipFill>
+          <a:blip r:embed="rId5"/>
+          <a:stretch>
+            <a:fillRect/>
+          </a:stretch>
+        </p:blipFill>
+        <p:spPr>
+          <a:xfrm rot="360000">
+            <a:off x="9430207" y="3703320"/>
+            <a:ext cx="548640" cy="548640"/>
+          </a:xfrm>
+          <a:prstGeom prst="rect">
+            <a:avLst/>
+          </a:prstGeom>
+        </p:spPr>
+      </p:pic>
+      <p:pic>
+        <p:nvPicPr>
+          <p:cNvPr id="22" name="بصمة 21" descr="fp1.png"/>
+          <p:cNvPicPr>
+            <a:picLocks noChangeAspect="1"/>
+          </p:cNvPicPr>
+          <p:nvPr/>
+        </p:nvPicPr>
+        <p:blipFill>
+          <a:blip r:embed="rId6"/>
+          <a:stretch>
+            <a:fillRect/>
+          </a:stretch>
+        </p:blipFill>
+        <p:spPr>
+          <a:xfrm rot="21360000">
+            <a:off x="8844991" y="3703320"/>
+            <a:ext cx="548640" cy="548640"/>
+          </a:xfrm>
+          <a:prstGeom prst="rect">
+            <a:avLst/>
+          </a:prstGeom>
+        </p:spPr>
+      </p:pic>
+      <p:pic>
+        <p:nvPicPr>
+          <p:cNvPr id="23" name="بصمة 23" descr="fp2.png"/>
+          <p:cNvPicPr>
+            <a:picLocks noChangeAspect="1"/>
+          </p:cNvPicPr>
+          <p:nvPr/>
+        </p:nvPicPr>
+        <p:blipFill>
+          <a:blip r:embed="rId7"/>
+          <a:stretch>
+            <a:fillRect/>
+          </a:stretch>
+        </p:blipFill>
+        <p:spPr>
+          <a:xfrm rot="180000">
+            <a:off x="8259775" y="3703320"/>
+            <a:ext cx="548640" cy="548640"/>
+          </a:xfrm>
+          <a:prstGeom prst="rect">
+            <a:avLst/>
+          </a:prstGeom>
+        </p:spPr>
+      </p:pic>
+      <p:pic>
+        <p:nvPicPr>
+          <p:cNvPr id="24" name="بصمة 02" descr="fp0.png"/>
+          <p:cNvPicPr>
+            <a:picLocks noChangeAspect="1"/>
+          </p:cNvPicPr>
+          <p:nvPr/>
+        </p:nvPicPr>
+        <p:blipFill>
+          <a:blip r:embed="rId5"/>
+          <a:stretch>
+            <a:fillRect/>
+          </a:stretch>
+        </p:blipFill>
+        <p:spPr>
+          <a:xfrm rot="360000">
+            <a:off x="457200" y="2514600"/>
+            <a:ext cx="548640" cy="548640"/>
+          </a:xfrm>
+          <a:prstGeom prst="rect">
+            <a:avLst/>
+          </a:prstGeom>
+        </p:spPr>
+      </p:pic>
+      <p:pic>
+        <p:nvPicPr>
+          <p:cNvPr id="25" name="بصمة 04" descr="fp1.png"/>
+          <p:cNvPicPr>
+            <a:picLocks noChangeAspect="1"/>
+          </p:cNvPicPr>
+          <p:nvPr/>
+        </p:nvPicPr>
+        <p:blipFill>
+          <a:blip r:embed="rId6"/>
+          <a:stretch>
+            <a:fillRect/>
+          </a:stretch>
+        </p:blipFill>
+        <p:spPr>
+          <a:xfrm rot="21360000">
+            <a:off x="1042416" y="2514600"/>
+            <a:ext cx="548640" cy="548640"/>
+          </a:xfrm>
+          <a:prstGeom prst="rect">
+            <a:avLst/>
+          </a:prstGeom>
+        </p:spPr>
+      </p:pic>
+      <p:pic>
+        <p:nvPicPr>
+          <p:cNvPr id="26" name="بصمة 06" descr="fp2.png"/>
+          <p:cNvPicPr>
+            <a:picLocks noChangeAspect="1"/>
+          </p:cNvPicPr>
+          <p:nvPr/>
+        </p:nvPicPr>
+        <p:blipFill>
+          <a:blip r:embed="rId7"/>
+          <a:stretch>
+            <a:fillRect/>
+          </a:stretch>
+        </p:blipFill>
+        <p:spPr>
+          <a:xfrm rot="180000">
+            <a:off x="1627632" y="2514600"/>
+            <a:ext cx="548640" cy="548640"/>
+          </a:xfrm>
+          <a:prstGeom prst="rect">
+            <a:avLst/>
+          </a:prstGeom>
+        </p:spPr>
+      </p:pic>
+      <p:pic>
+        <p:nvPicPr>
+          <p:cNvPr id="27" name="بصمة 08" descr="fp3.png"/>
+          <p:cNvPicPr>
+            <a:picLocks noChangeAspect="1"/>
+          </p:cNvPicPr>
+          <p:nvPr/>
+        </p:nvPicPr>
+        <p:blipFill>
+          <a:blip r:embed="rId8"/>
+          <a:stretch>
+            <a:fillRect/>
+          </a:stretch>
+        </p:blipFill>
+        <p:spPr>
+          <a:xfrm rot="21240000">
+            <a:off x="2212848" y="2514600"/>
+            <a:ext cx="548640" cy="548640"/>
+          </a:xfrm>
+          <a:prstGeom prst="rect">
+            <a:avLst/>
+          </a:prstGeom>
+        </p:spPr>
+      </p:pic>
+      <p:pic>
+        <p:nvPicPr>
+          <p:cNvPr id="28" name="بصمة 10" descr="fp0.png"/>
+          <p:cNvPicPr>
+            <a:picLocks noChangeAspect="1"/>
+          </p:cNvPicPr>
+          <p:nvPr/>
+        </p:nvPicPr>
+        <p:blipFill>
+          <a:blip r:embed="rId5"/>
+          <a:stretch>
+            <a:fillRect/>
+          </a:stretch>
+        </p:blipFill>
+        <p:spPr>
+          <a:xfrm rot="240000">
+            <a:off x="2798064" y="2514600"/>
+            <a:ext cx="548640" cy="548640"/>
+          </a:xfrm>
+          <a:prstGeom prst="rect">
+            <a:avLst/>
+          </a:prstGeom>
+        </p:spPr>
+      </p:pic>
+      <p:pic>
+        <p:nvPicPr>
+          <p:cNvPr id="29" name="بصمة 12" descr="fp1.png"/>
+          <p:cNvPicPr>
+            <a:picLocks noChangeAspect="1"/>
+          </p:cNvPicPr>
+          <p:nvPr/>
+        </p:nvPicPr>
+        <p:blipFill>
+          <a:blip r:embed="rId6"/>
+          <a:stretch>
+            <a:fillRect/>
+          </a:stretch>
+        </p:blipFill>
+        <p:spPr>
+          <a:xfrm rot="21420000">
+            <a:off x="3383280" y="2514600"/>
+            <a:ext cx="548640" cy="548640"/>
+          </a:xfrm>
+          <a:prstGeom prst="rect">
+            <a:avLst/>
+          </a:prstGeom>
+        </p:spPr>
+      </p:pic>
+      <p:pic>
+        <p:nvPicPr>
+          <p:cNvPr id="30" name="بصمة 14" descr="fp1.png"/>
+          <p:cNvPicPr>
+            <a:picLocks noChangeAspect="1"/>
+          </p:cNvPicPr>
+          <p:nvPr/>
+        </p:nvPicPr>
+        <p:blipFill>
+          <a:blip r:embed="rId6"/>
+          <a:stretch>
+            <a:fillRect/>
+          </a:stretch>
+        </p:blipFill>
+        <p:spPr>
+          <a:xfrm rot="360000">
+            <a:off x="457200" y="3703320"/>
+            <a:ext cx="548640" cy="548640"/>
+          </a:xfrm>
+          <a:prstGeom prst="rect">
+            <a:avLst/>
+          </a:prstGeom>
+        </p:spPr>
+      </p:pic>
+      <p:pic>
+        <p:nvPicPr>
+          <p:cNvPr id="31" name="بصمة 16" descr="fp2.png"/>
           <p:cNvPicPr>
             <a:picLocks noChangeAspect="1"/>
           </p:cNvPicPr>
@@ -3995,8 +4403,8 @@
         </p:blipFill>
         <p:spPr>
           <a:xfrm rot="21360000">
-            <a:off x="9006840" y="1572768"/>
-            <a:ext cx="777240" cy="777240"/>
+            <a:off x="1042416" y="3703320"/>
+            <a:ext cx="548640" cy="548640"/>
           </a:xfrm>
           <a:prstGeom prst="rect">
             <a:avLst/>
@@ -4005,55 +4413,7 @@
       </p:pic>
       <p:pic>
         <p:nvPicPr>
-          <p:cNvPr id="15" name="بصمة 11" descr="fp1.png"/>
-          <p:cNvPicPr>
-            <a:picLocks noChangeAspect="1"/>
-          </p:cNvPicPr>
-          <p:nvPr/>
-        </p:nvPicPr>
-        <p:blipFill>
-          <a:blip r:embed="rId6"/>
-          <a:stretch>
-            <a:fillRect/>
-          </a:stretch>
-        </p:blipFill>
-        <p:spPr>
-          <a:xfrm rot="720000">
-            <a:off x="11018520" y="2487168"/>
-            <a:ext cx="777240" cy="777240"/>
-          </a:xfrm>
-          <a:prstGeom prst="rect">
-            <a:avLst/>
-          </a:prstGeom>
-        </p:spPr>
-      </p:pic>
-      <p:pic>
-        <p:nvPicPr>
-          <p:cNvPr id="16" name="بصمة 09" descr="fp2.png"/>
-          <p:cNvPicPr>
-            <a:picLocks noChangeAspect="1"/>
-          </p:cNvPicPr>
-          <p:nvPr/>
-        </p:nvPicPr>
-        <p:blipFill>
-          <a:blip r:embed="rId7"/>
-          <a:stretch>
-            <a:fillRect/>
-          </a:stretch>
-        </p:blipFill>
-        <p:spPr>
-          <a:xfrm rot="21060000">
-            <a:off x="10012680" y="2688336"/>
-            <a:ext cx="777240" cy="777240"/>
-          </a:xfrm>
-          <a:prstGeom prst="rect">
-            <a:avLst/>
-          </a:prstGeom>
-        </p:spPr>
-      </p:pic>
-      <p:pic>
-        <p:nvPicPr>
-          <p:cNvPr id="17" name="بصمة 07" descr="fp3.png"/>
+          <p:cNvPr id="32" name="بصمة 18" descr="fp3.png"/>
           <p:cNvPicPr>
             <a:picLocks noChangeAspect="1"/>
           </p:cNvPicPr>
@@ -4066,9 +4426,9 @@
           </a:stretch>
         </p:blipFill>
         <p:spPr>
-          <a:xfrm rot="300000">
-            <a:off x="9006840" y="2487168"/>
-            <a:ext cx="777240" cy="777240"/>
+          <a:xfrm rot="180000">
+            <a:off x="1627632" y="3703320"/>
+            <a:ext cx="548640" cy="548640"/>
           </a:xfrm>
           <a:prstGeom prst="rect">
             <a:avLst/>
@@ -4077,55 +4437,7 @@
       </p:pic>
       <p:pic>
         <p:nvPicPr>
-          <p:cNvPr id="18" name="بصمة 17" descr="fp2.png"/>
-          <p:cNvPicPr>
-            <a:picLocks noChangeAspect="1"/>
-          </p:cNvPicPr>
-          <p:nvPr/>
-        </p:nvPicPr>
-        <p:blipFill>
-          <a:blip r:embed="rId7"/>
-          <a:stretch>
-            <a:fillRect/>
-          </a:stretch>
-        </p:blipFill>
-        <p:spPr>
-          <a:xfrm rot="900000">
-            <a:off x="11018520" y="3401568"/>
-            <a:ext cx="777240" cy="777240"/>
-          </a:xfrm>
-          <a:prstGeom prst="rect">
-            <a:avLst/>
-          </a:prstGeom>
-        </p:spPr>
-      </p:pic>
-      <p:pic>
-        <p:nvPicPr>
-          <p:cNvPr id="19" name="بصمة 15" descr="fp3.png"/>
-          <p:cNvPicPr>
-            <a:picLocks noChangeAspect="1"/>
-          </p:cNvPicPr>
-          <p:nvPr/>
-        </p:nvPicPr>
-        <p:blipFill>
-          <a:blip r:embed="rId8"/>
-          <a:stretch>
-            <a:fillRect/>
-          </a:stretch>
-        </p:blipFill>
-        <p:spPr>
-          <a:xfrm rot="21240000">
-            <a:off x="10012680" y="3602736"/>
-            <a:ext cx="777240" cy="777240"/>
-          </a:xfrm>
-          <a:prstGeom prst="rect">
-            <a:avLst/>
-          </a:prstGeom>
-        </p:spPr>
-      </p:pic>
-      <p:pic>
-        <p:nvPicPr>
-          <p:cNvPr id="20" name="بصمة 13" descr="fp0.png"/>
+          <p:cNvPr id="33" name="بصمة 20" descr="fp0.png"/>
           <p:cNvPicPr>
             <a:picLocks noChangeAspect="1"/>
           </p:cNvPicPr>
@@ -4138,321 +4450,9 @@
           </a:stretch>
         </p:blipFill>
         <p:spPr>
-          <a:xfrm rot="600000">
-            <a:off x="9006840" y="3401568"/>
-            <a:ext cx="777240" cy="777240"/>
-          </a:xfrm>
-          <a:prstGeom prst="rect">
-            <a:avLst/>
-          </a:prstGeom>
-        </p:spPr>
-      </p:pic>
-      <p:pic>
-        <p:nvPicPr>
-          <p:cNvPr id="21" name="بصمة 23" descr="fp3.png"/>
-          <p:cNvPicPr>
-            <a:picLocks noChangeAspect="1"/>
-          </p:cNvPicPr>
-          <p:nvPr/>
-        </p:nvPicPr>
-        <p:blipFill>
-          <a:blip r:embed="rId8"/>
-          <a:stretch>
-            <a:fillRect/>
-          </a:stretch>
-        </p:blipFill>
-        <p:spPr>
-          <a:xfrm rot="20880000">
-            <a:off x="11018520" y="4315968"/>
-            <a:ext cx="777240" cy="777240"/>
-          </a:xfrm>
-          <a:prstGeom prst="rect">
-            <a:avLst/>
-          </a:prstGeom>
-        </p:spPr>
-      </p:pic>
-      <p:pic>
-        <p:nvPicPr>
-          <p:cNvPr id="22" name="بصمة 21" descr="fp0.png"/>
-          <p:cNvPicPr>
-            <a:picLocks noChangeAspect="1"/>
-          </p:cNvPicPr>
-          <p:nvPr/>
-        </p:nvPicPr>
-        <p:blipFill>
-          <a:blip r:embed="rId5"/>
-          <a:stretch>
-            <a:fillRect/>
-          </a:stretch>
-        </p:blipFill>
-        <p:spPr>
-          <a:xfrm rot="180000">
-            <a:off x="10012680" y="4517136"/>
-            <a:ext cx="777240" cy="777240"/>
-          </a:xfrm>
-          <a:prstGeom prst="rect">
-            <a:avLst/>
-          </a:prstGeom>
-        </p:spPr>
-      </p:pic>
-      <p:pic>
-        <p:nvPicPr>
-          <p:cNvPr id="23" name="بصمة 19" descr="fp1.png"/>
-          <p:cNvPicPr>
-            <a:picLocks noChangeAspect="1"/>
-          </p:cNvPicPr>
-          <p:nvPr/>
-        </p:nvPicPr>
-        <p:blipFill>
-          <a:blip r:embed="rId6"/>
-          <a:stretch>
-            <a:fillRect/>
-          </a:stretch>
-        </p:blipFill>
-        <p:spPr>
-          <a:xfrm rot="21120000">
-            <a:off x="9006840" y="4315968"/>
-            <a:ext cx="777240" cy="777240"/>
-          </a:xfrm>
-          <a:prstGeom prst="rect">
-            <a:avLst/>
-          </a:prstGeom>
-        </p:spPr>
-      </p:pic>
-      <p:pic>
-        <p:nvPicPr>
-          <p:cNvPr id="24" name="بصمة 06" descr="fp1.png"/>
-          <p:cNvPicPr>
-            <a:picLocks noChangeAspect="1"/>
-          </p:cNvPicPr>
-          <p:nvPr/>
-        </p:nvPicPr>
-        <p:blipFill>
-          <a:blip r:embed="rId6"/>
-          <a:stretch>
-            <a:fillRect/>
-          </a:stretch>
-        </p:blipFill>
-        <p:spPr>
-          <a:xfrm rot="840000">
-            <a:off x="411480" y="1572768"/>
-            <a:ext cx="777240" cy="777240"/>
-          </a:xfrm>
-          <a:prstGeom prst="rect">
-            <a:avLst/>
-          </a:prstGeom>
-        </p:spPr>
-      </p:pic>
-      <p:pic>
-        <p:nvPicPr>
-          <p:cNvPr id="25" name="بصمة 04" descr="fp2.png"/>
-          <p:cNvPicPr>
-            <a:picLocks noChangeAspect="1"/>
-          </p:cNvPicPr>
-          <p:nvPr/>
-        </p:nvPicPr>
-        <p:blipFill>
-          <a:blip r:embed="rId7"/>
-          <a:stretch>
-            <a:fillRect/>
-          </a:stretch>
-        </p:blipFill>
-        <p:spPr>
-          <a:xfrm rot="21120000">
-            <a:off x="1417320" y="1773936"/>
-            <a:ext cx="777240" cy="777240"/>
-          </a:xfrm>
-          <a:prstGeom prst="rect">
-            <a:avLst/>
-          </a:prstGeom>
-        </p:spPr>
-      </p:pic>
-      <p:pic>
-        <p:nvPicPr>
-          <p:cNvPr id="26" name="بصمة 02" descr="fp3.png"/>
-          <p:cNvPicPr>
-            <a:picLocks noChangeAspect="1"/>
-          </p:cNvPicPr>
-          <p:nvPr/>
-        </p:nvPicPr>
-        <p:blipFill>
-          <a:blip r:embed="rId8"/>
-          <a:stretch>
-            <a:fillRect/>
-          </a:stretch>
-        </p:blipFill>
-        <p:spPr>
-          <a:xfrm rot="240000">
-            <a:off x="2423160" y="1572768"/>
-            <a:ext cx="777240" cy="777240"/>
-          </a:xfrm>
-          <a:prstGeom prst="rect">
-            <a:avLst/>
-          </a:prstGeom>
-        </p:spPr>
-      </p:pic>
-      <p:pic>
-        <p:nvPicPr>
-          <p:cNvPr id="27" name="بصمة 12" descr="fp2.png"/>
-          <p:cNvPicPr>
-            <a:picLocks noChangeAspect="1"/>
-          </p:cNvPicPr>
-          <p:nvPr/>
-        </p:nvPicPr>
-        <p:blipFill>
-          <a:blip r:embed="rId7"/>
-          <a:stretch>
-            <a:fillRect/>
-          </a:stretch>
-        </p:blipFill>
-        <p:spPr>
-          <a:xfrm rot="20880000">
-            <a:off x="411480" y="2487168"/>
-            <a:ext cx="777240" cy="777240"/>
-          </a:xfrm>
-          <a:prstGeom prst="rect">
-            <a:avLst/>
-          </a:prstGeom>
-        </p:spPr>
-      </p:pic>
-      <p:pic>
-        <p:nvPicPr>
-          <p:cNvPr id="28" name="بصمة 10" descr="fp3.png"/>
-          <p:cNvPicPr>
-            <a:picLocks noChangeAspect="1"/>
-          </p:cNvPicPr>
-          <p:nvPr/>
-        </p:nvPicPr>
-        <p:blipFill>
-          <a:blip r:embed="rId8"/>
-          <a:stretch>
-            <a:fillRect/>
-          </a:stretch>
-        </p:blipFill>
-        <p:spPr>
-          <a:xfrm rot="540000">
-            <a:off x="1417320" y="2688336"/>
-            <a:ext cx="777240" cy="777240"/>
-          </a:xfrm>
-          <a:prstGeom prst="rect">
-            <a:avLst/>
-          </a:prstGeom>
-        </p:spPr>
-      </p:pic>
-      <p:pic>
-        <p:nvPicPr>
-          <p:cNvPr id="29" name="بصمة 08" descr="fp0.png"/>
-          <p:cNvPicPr>
-            <a:picLocks noChangeAspect="1"/>
-          </p:cNvPicPr>
-          <p:nvPr/>
-        </p:nvPicPr>
-        <p:blipFill>
-          <a:blip r:embed="rId5"/>
-          <a:stretch>
-            <a:fillRect/>
-          </a:stretch>
-        </p:blipFill>
-        <p:spPr>
-          <a:xfrm rot="21300000">
-            <a:off x="2423160" y="2487168"/>
-            <a:ext cx="777240" cy="777240"/>
-          </a:xfrm>
-          <a:prstGeom prst="rect">
-            <a:avLst/>
-          </a:prstGeom>
-        </p:spPr>
-      </p:pic>
-      <p:pic>
-        <p:nvPicPr>
-          <p:cNvPr id="30" name="بصمة 18" descr="fp3.png"/>
-          <p:cNvPicPr>
-            <a:picLocks noChangeAspect="1"/>
-          </p:cNvPicPr>
-          <p:nvPr/>
-        </p:nvPicPr>
-        <p:blipFill>
-          <a:blip r:embed="rId8"/>
-          <a:stretch>
-            <a:fillRect/>
-          </a:stretch>
-        </p:blipFill>
-        <p:spPr>
-          <a:xfrm rot="20700000">
-            <a:off x="411480" y="3401568"/>
-            <a:ext cx="777240" cy="777240"/>
-          </a:xfrm>
-          <a:prstGeom prst="rect">
-            <a:avLst/>
-          </a:prstGeom>
-        </p:spPr>
-      </p:pic>
-      <p:pic>
-        <p:nvPicPr>
-          <p:cNvPr id="31" name="بصمة 16" descr="fp0.png"/>
-          <p:cNvPicPr>
-            <a:picLocks noChangeAspect="1"/>
-          </p:cNvPicPr>
-          <p:nvPr/>
-        </p:nvPicPr>
-        <p:blipFill>
-          <a:blip r:embed="rId5"/>
-          <a:stretch>
-            <a:fillRect/>
-          </a:stretch>
-        </p:blipFill>
-        <p:spPr>
-          <a:xfrm rot="360000">
-            <a:off x="1417320" y="3602736"/>
-            <a:ext cx="777240" cy="777240"/>
-          </a:xfrm>
-          <a:prstGeom prst="rect">
-            <a:avLst/>
-          </a:prstGeom>
-        </p:spPr>
-      </p:pic>
-      <p:pic>
-        <p:nvPicPr>
-          <p:cNvPr id="32" name="بصمة 14" descr="fp1.png"/>
-          <p:cNvPicPr>
-            <a:picLocks noChangeAspect="1"/>
-          </p:cNvPicPr>
-          <p:nvPr/>
-        </p:nvPicPr>
-        <p:blipFill>
-          <a:blip r:embed="rId6"/>
-          <a:stretch>
-            <a:fillRect/>
-          </a:stretch>
-        </p:blipFill>
-        <p:spPr>
-          <a:xfrm rot="21000000">
-            <a:off x="2423160" y="3401568"/>
-            <a:ext cx="777240" cy="777240"/>
-          </a:xfrm>
-          <a:prstGeom prst="rect">
-            <a:avLst/>
-          </a:prstGeom>
-        </p:spPr>
-      </p:pic>
-      <p:pic>
-        <p:nvPicPr>
-          <p:cNvPr id="33" name="بصمة 24" descr="fp0.png"/>
-          <p:cNvPicPr>
-            <a:picLocks noChangeAspect="1"/>
-          </p:cNvPicPr>
-          <p:nvPr/>
-        </p:nvPicPr>
-        <p:blipFill>
-          <a:blip r:embed="rId5"/>
-          <a:stretch>
-            <a:fillRect/>
-          </a:stretch>
-        </p:blipFill>
-        <p:spPr>
-          <a:xfrm rot="720000">
-            <a:off x="411480" y="4315968"/>
-            <a:ext cx="777240" cy="777240"/>
+          <a:xfrm rot="21240000">
+            <a:off x="2212848" y="3703320"/>
+            <a:ext cx="548640" cy="548640"/>
           </a:xfrm>
           <a:prstGeom prst="rect">
             <a:avLst/>
@@ -4474,9 +4474,9 @@
           </a:stretch>
         </p:blipFill>
         <p:spPr>
-          <a:xfrm rot="21420000">
-            <a:off x="1417320" y="4517136"/>
-            <a:ext cx="777240" cy="777240"/>
+          <a:xfrm rot="240000">
+            <a:off x="2798064" y="3703320"/>
+            <a:ext cx="548640" cy="548640"/>
           </a:xfrm>
           <a:prstGeom prst="rect">
             <a:avLst/>
@@ -4485,7 +4485,7 @@
       </p:pic>
       <p:pic>
         <p:nvPicPr>
-          <p:cNvPr id="35" name="بصمة 20" descr="fp2.png"/>
+          <p:cNvPr id="35" name="بصمة 24" descr="fp2.png"/>
           <p:cNvPicPr>
             <a:picLocks noChangeAspect="1"/>
           </p:cNvPicPr>
@@ -4498,9 +4498,9 @@
           </a:stretch>
         </p:blipFill>
         <p:spPr>
-          <a:xfrm rot="480000">
-            <a:off x="2423160" y="4315968"/>
-            <a:ext cx="777240" cy="777240"/>
+          <a:xfrm rot="21420000">
+            <a:off x="3383280" y="3703320"/>
+            <a:ext cx="548640" cy="548640"/>
           </a:xfrm>
           <a:prstGeom prst="rect">
             <a:avLst/>
@@ -4546,7 +4546,7 @@
                                           </p:stCondLst>
                                         </p:cTn>
                                         <p:tgtEl>
-                                          <p:spTgt spid="14"/>
+                                          <p:spTgt spid="12"/>
                                         </p:tgtEl>
                                         <p:attrNameLst>
                                           <p:attrName>style.visibility</p:attrName>
@@ -4560,7 +4560,7 @@
                                       <p:cBhvr>
                                         <p:cTn id="7" dur="900" fill="hold"/>
                                         <p:tgtEl>
-                                          <p:spTgt spid="14"/>
+                                          <p:spTgt spid="12"/>
                                         </p:tgtEl>
                                         <p:attrNameLst>
                                           <p:attrName>ppt_w</p:attrName>
@@ -4583,7 +4583,7 @@
                                       <p:cBhvr>
                                         <p:cTn id="8" dur="900" fill="hold"/>
                                         <p:tgtEl>
-                                          <p:spTgt spid="14"/>
+                                          <p:spTgt spid="12"/>
                                         </p:tgtEl>
                                         <p:attrNameLst>
                                           <p:attrName>ppt_h</p:attrName>
@@ -4606,7 +4606,7 @@
                                       <p:cBhvr>
                                         <p:cTn id="9" dur="900"/>
                                         <p:tgtEl>
-                                          <p:spTgt spid="14"/>
+                                          <p:spTgt spid="12"/>
                                         </p:tgtEl>
                                       </p:cBhvr>
                                     </p:animEffect>
@@ -4645,7 +4645,7 @@
                                           </p:stCondLst>
                                         </p:cTn>
                                         <p:tgtEl>
-                                          <p:spTgt spid="26"/>
+                                          <p:spTgt spid="24"/>
                                         </p:tgtEl>
                                         <p:attrNameLst>
                                           <p:attrName>style.visibility</p:attrName>
@@ -4659,7 +4659,7 @@
                                       <p:cBhvr>
                                         <p:cTn id="14" dur="900" fill="hold"/>
                                         <p:tgtEl>
-                                          <p:spTgt spid="26"/>
+                                          <p:spTgt spid="24"/>
                                         </p:tgtEl>
                                         <p:attrNameLst>
                                           <p:attrName>ppt_w</p:attrName>
@@ -4682,7 +4682,7 @@
                                       <p:cBhvr>
                                         <p:cTn id="15" dur="900" fill="hold"/>
                                         <p:tgtEl>
-                                          <p:spTgt spid="26"/>
+                                          <p:spTgt spid="24"/>
                                         </p:tgtEl>
                                         <p:attrNameLst>
                                           <p:attrName>ppt_h</p:attrName>
@@ -4705,7 +4705,7 @@
                                       <p:cBhvr>
                                         <p:cTn id="16" dur="900"/>
                                         <p:tgtEl>
-                                          <p:spTgt spid="26"/>
+                                          <p:spTgt spid="24"/>
                                         </p:tgtEl>
                                       </p:cBhvr>
                                     </p:animEffect>
@@ -4942,7 +4942,7 @@
                                           </p:stCondLst>
                                         </p:cTn>
                                         <p:tgtEl>
-                                          <p:spTgt spid="12"/>
+                                          <p:spTgt spid="14"/>
                                         </p:tgtEl>
                                         <p:attrNameLst>
                                           <p:attrName>style.visibility</p:attrName>
@@ -4956,7 +4956,7 @@
                                       <p:cBhvr>
                                         <p:cTn id="35" dur="900" fill="hold"/>
                                         <p:tgtEl>
-                                          <p:spTgt spid="12"/>
+                                          <p:spTgt spid="14"/>
                                         </p:tgtEl>
                                         <p:attrNameLst>
                                           <p:attrName>ppt_w</p:attrName>
@@ -4979,7 +4979,7 @@
                                       <p:cBhvr>
                                         <p:cTn id="36" dur="900" fill="hold"/>
                                         <p:tgtEl>
-                                          <p:spTgt spid="12"/>
+                                          <p:spTgt spid="14"/>
                                         </p:tgtEl>
                                         <p:attrNameLst>
                                           <p:attrName>ppt_h</p:attrName>
@@ -5002,7 +5002,7 @@
                                       <p:cBhvr>
                                         <p:cTn id="37" dur="900"/>
                                         <p:tgtEl>
-                                          <p:spTgt spid="12"/>
+                                          <p:spTgt spid="14"/>
                                         </p:tgtEl>
                                       </p:cBhvr>
                                     </p:animEffect>
@@ -5041,7 +5041,7 @@
                                           </p:stCondLst>
                                         </p:cTn>
                                         <p:tgtEl>
-                                          <p:spTgt spid="24"/>
+                                          <p:spTgt spid="26"/>
                                         </p:tgtEl>
                                         <p:attrNameLst>
                                           <p:attrName>style.visibility</p:attrName>
@@ -5055,7 +5055,7 @@
                                       <p:cBhvr>
                                         <p:cTn id="42" dur="900" fill="hold"/>
                                         <p:tgtEl>
-                                          <p:spTgt spid="24"/>
+                                          <p:spTgt spid="26"/>
                                         </p:tgtEl>
                                         <p:attrNameLst>
                                           <p:attrName>ppt_w</p:attrName>
@@ -5078,7 +5078,7 @@
                                       <p:cBhvr>
                                         <p:cTn id="43" dur="900" fill="hold"/>
                                         <p:tgtEl>
-                                          <p:spTgt spid="24"/>
+                                          <p:spTgt spid="26"/>
                                         </p:tgtEl>
                                         <p:attrNameLst>
                                           <p:attrName>ppt_h</p:attrName>
@@ -5101,7 +5101,7 @@
                                       <p:cBhvr>
                                         <p:cTn id="44" dur="900"/>
                                         <p:tgtEl>
-                                          <p:spTgt spid="24"/>
+                                          <p:spTgt spid="26"/>
                                         </p:tgtEl>
                                       </p:cBhvr>
                                     </p:animEffect>
@@ -5140,7 +5140,7 @@
                                           </p:stCondLst>
                                         </p:cTn>
                                         <p:tgtEl>
-                                          <p:spTgt spid="17"/>
+                                          <p:spTgt spid="15"/>
                                         </p:tgtEl>
                                         <p:attrNameLst>
                                           <p:attrName>style.visibility</p:attrName>
@@ -5154,7 +5154,7 @@
                                       <p:cBhvr>
                                         <p:cTn id="49" dur="900" fill="hold"/>
                                         <p:tgtEl>
-                                          <p:spTgt spid="17"/>
+                                          <p:spTgt spid="15"/>
                                         </p:tgtEl>
                                         <p:attrNameLst>
                                           <p:attrName>ppt_w</p:attrName>
@@ -5177,7 +5177,7 @@
                                       <p:cBhvr>
                                         <p:cTn id="50" dur="900" fill="hold"/>
                                         <p:tgtEl>
-                                          <p:spTgt spid="17"/>
+                                          <p:spTgt spid="15"/>
                                         </p:tgtEl>
                                         <p:attrNameLst>
                                           <p:attrName>ppt_h</p:attrName>
@@ -5200,7 +5200,7 @@
                                       <p:cBhvr>
                                         <p:cTn id="51" dur="900"/>
                                         <p:tgtEl>
-                                          <p:spTgt spid="17"/>
+                                          <p:spTgt spid="15"/>
                                         </p:tgtEl>
                                       </p:cBhvr>
                                     </p:animEffect>
@@ -5239,7 +5239,7 @@
                                           </p:stCondLst>
                                         </p:cTn>
                                         <p:tgtEl>
-                                          <p:spTgt spid="29"/>
+                                          <p:spTgt spid="27"/>
                                         </p:tgtEl>
                                         <p:attrNameLst>
                                           <p:attrName>style.visibility</p:attrName>
@@ -5253,7 +5253,7 @@
                                       <p:cBhvr>
                                         <p:cTn id="56" dur="900" fill="hold"/>
                                         <p:tgtEl>
-                                          <p:spTgt spid="29"/>
+                                          <p:spTgt spid="27"/>
                                         </p:tgtEl>
                                         <p:attrNameLst>
                                           <p:attrName>ppt_w</p:attrName>
@@ -5276,7 +5276,7 @@
                                       <p:cBhvr>
                                         <p:cTn id="57" dur="900" fill="hold"/>
                                         <p:tgtEl>
-                                          <p:spTgt spid="29"/>
+                                          <p:spTgt spid="27"/>
                                         </p:tgtEl>
                                         <p:attrNameLst>
                                           <p:attrName>ppt_h</p:attrName>
@@ -5299,7 +5299,7 @@
                                       <p:cBhvr>
                                         <p:cTn id="58" dur="900"/>
                                         <p:tgtEl>
-                                          <p:spTgt spid="29"/>
+                                          <p:spTgt spid="27"/>
                                         </p:tgtEl>
                                       </p:cBhvr>
                                     </p:animEffect>
@@ -5536,7 +5536,7 @@
                                           </p:stCondLst>
                                         </p:cTn>
                                         <p:tgtEl>
-                                          <p:spTgt spid="15"/>
+                                          <p:spTgt spid="17"/>
                                         </p:tgtEl>
                                         <p:attrNameLst>
                                           <p:attrName>style.visibility</p:attrName>
@@ -5550,7 +5550,7 @@
                                       <p:cBhvr>
                                         <p:cTn id="77" dur="900" fill="hold"/>
                                         <p:tgtEl>
-                                          <p:spTgt spid="15"/>
+                                          <p:spTgt spid="17"/>
                                         </p:tgtEl>
                                         <p:attrNameLst>
                                           <p:attrName>ppt_w</p:attrName>
@@ -5573,7 +5573,7 @@
                                       <p:cBhvr>
                                         <p:cTn id="78" dur="900" fill="hold"/>
                                         <p:tgtEl>
-                                          <p:spTgt spid="15"/>
+                                          <p:spTgt spid="17"/>
                                         </p:tgtEl>
                                         <p:attrNameLst>
                                           <p:attrName>ppt_h</p:attrName>
@@ -5596,7 +5596,7 @@
                                       <p:cBhvr>
                                         <p:cTn id="79" dur="900"/>
                                         <p:tgtEl>
-                                          <p:spTgt spid="15"/>
+                                          <p:spTgt spid="17"/>
                                         </p:tgtEl>
                                       </p:cBhvr>
                                     </p:animEffect>
@@ -5635,7 +5635,7 @@
                                           </p:stCondLst>
                                         </p:cTn>
                                         <p:tgtEl>
-                                          <p:spTgt spid="27"/>
+                                          <p:spTgt spid="29"/>
                                         </p:tgtEl>
                                         <p:attrNameLst>
                                           <p:attrName>style.visibility</p:attrName>
@@ -5649,7 +5649,7 @@
                                       <p:cBhvr>
                                         <p:cTn id="84" dur="900" fill="hold"/>
                                         <p:tgtEl>
-                                          <p:spTgt spid="27"/>
+                                          <p:spTgt spid="29"/>
                                         </p:tgtEl>
                                         <p:attrNameLst>
                                           <p:attrName>ppt_w</p:attrName>
@@ -5672,7 +5672,7 @@
                                       <p:cBhvr>
                                         <p:cTn id="85" dur="900" fill="hold"/>
                                         <p:tgtEl>
-                                          <p:spTgt spid="27"/>
+                                          <p:spTgt spid="29"/>
                                         </p:tgtEl>
                                         <p:attrNameLst>
                                           <p:attrName>ppt_h</p:attrName>
@@ -5695,7 +5695,7 @@
                                       <p:cBhvr>
                                         <p:cTn id="86" dur="900"/>
                                         <p:tgtEl>
-                                          <p:spTgt spid="27"/>
+                                          <p:spTgt spid="29"/>
                                         </p:tgtEl>
                                       </p:cBhvr>
                                     </p:animEffect>
@@ -5734,7 +5734,7 @@
                                           </p:stCondLst>
                                         </p:cTn>
                                         <p:tgtEl>
-                                          <p:spTgt spid="20"/>
+                                          <p:spTgt spid="18"/>
                                         </p:tgtEl>
                                         <p:attrNameLst>
                                           <p:attrName>style.visibility</p:attrName>
@@ -5748,7 +5748,7 @@
                                       <p:cBhvr>
                                         <p:cTn id="91" dur="900" fill="hold"/>
                                         <p:tgtEl>
-                                          <p:spTgt spid="20"/>
+                                          <p:spTgt spid="18"/>
                                         </p:tgtEl>
                                         <p:attrNameLst>
                                           <p:attrName>ppt_w</p:attrName>
@@ -5771,7 +5771,7 @@
                                       <p:cBhvr>
                                         <p:cTn id="92" dur="900" fill="hold"/>
                                         <p:tgtEl>
-                                          <p:spTgt spid="20"/>
+                                          <p:spTgt spid="18"/>
                                         </p:tgtEl>
                                         <p:attrNameLst>
                                           <p:attrName>ppt_h</p:attrName>
@@ -5794,7 +5794,7 @@
                                       <p:cBhvr>
                                         <p:cTn id="93" dur="900"/>
                                         <p:tgtEl>
-                                          <p:spTgt spid="20"/>
+                                          <p:spTgt spid="18"/>
                                         </p:tgtEl>
                                       </p:cBhvr>
                                     </p:animEffect>
@@ -5833,7 +5833,7 @@
                                           </p:stCondLst>
                                         </p:cTn>
                                         <p:tgtEl>
-                                          <p:spTgt spid="32"/>
+                                          <p:spTgt spid="30"/>
                                         </p:tgtEl>
                                         <p:attrNameLst>
                                           <p:attrName>style.visibility</p:attrName>
@@ -5847,7 +5847,7 @@
                                       <p:cBhvr>
                                         <p:cTn id="98" dur="900" fill="hold"/>
                                         <p:tgtEl>
-                                          <p:spTgt spid="32"/>
+                                          <p:spTgt spid="30"/>
                                         </p:tgtEl>
                                         <p:attrNameLst>
                                           <p:attrName>ppt_w</p:attrName>
@@ -5870,7 +5870,7 @@
                                       <p:cBhvr>
                                         <p:cTn id="99" dur="900" fill="hold"/>
                                         <p:tgtEl>
-                                          <p:spTgt spid="32"/>
+                                          <p:spTgt spid="30"/>
                                         </p:tgtEl>
                                         <p:attrNameLst>
                                           <p:attrName>ppt_h</p:attrName>
@@ -5893,7 +5893,7 @@
                                       <p:cBhvr>
                                         <p:cTn id="100" dur="900"/>
                                         <p:tgtEl>
-                                          <p:spTgt spid="32"/>
+                                          <p:spTgt spid="30"/>
                                         </p:tgtEl>
                                       </p:cBhvr>
                                     </p:animEffect>
@@ -6130,7 +6130,7 @@
                                           </p:stCondLst>
                                         </p:cTn>
                                         <p:tgtEl>
-                                          <p:spTgt spid="18"/>
+                                          <p:spTgt spid="20"/>
                                         </p:tgtEl>
                                         <p:attrNameLst>
                                           <p:attrName>style.visibility</p:attrName>
@@ -6144,7 +6144,7 @@
                                       <p:cBhvr>
                                         <p:cTn id="119" dur="900" fill="hold"/>
                                         <p:tgtEl>
-                                          <p:spTgt spid="18"/>
+                                          <p:spTgt spid="20"/>
                                         </p:tgtEl>
                                         <p:attrNameLst>
                                           <p:attrName>ppt_w</p:attrName>
@@ -6167,7 +6167,7 @@
                                       <p:cBhvr>
                                         <p:cTn id="120" dur="900" fill="hold"/>
                                         <p:tgtEl>
-                                          <p:spTgt spid="18"/>
+                                          <p:spTgt spid="20"/>
                                         </p:tgtEl>
                                         <p:attrNameLst>
                                           <p:attrName>ppt_h</p:attrName>
@@ -6190,7 +6190,7 @@
                                       <p:cBhvr>
                                         <p:cTn id="121" dur="900"/>
                                         <p:tgtEl>
-                                          <p:spTgt spid="18"/>
+                                          <p:spTgt spid="20"/>
                                         </p:tgtEl>
                                       </p:cBhvr>
                                     </p:animEffect>
@@ -6229,7 +6229,7 @@
                                           </p:stCondLst>
                                         </p:cTn>
                                         <p:tgtEl>
-                                          <p:spTgt spid="30"/>
+                                          <p:spTgt spid="32"/>
                                         </p:tgtEl>
                                         <p:attrNameLst>
                                           <p:attrName>style.visibility</p:attrName>
@@ -6243,7 +6243,7 @@
                                       <p:cBhvr>
                                         <p:cTn id="126" dur="900" fill="hold"/>
                                         <p:tgtEl>
-                                          <p:spTgt spid="30"/>
+                                          <p:spTgt spid="32"/>
                                         </p:tgtEl>
                                         <p:attrNameLst>
                                           <p:attrName>ppt_w</p:attrName>
@@ -6266,7 +6266,7 @@
                                       <p:cBhvr>
                                         <p:cTn id="127" dur="900" fill="hold"/>
                                         <p:tgtEl>
-                                          <p:spTgt spid="30"/>
+                                          <p:spTgt spid="32"/>
                                         </p:tgtEl>
                                         <p:attrNameLst>
                                           <p:attrName>ppt_h</p:attrName>
@@ -6289,7 +6289,7 @@
                                       <p:cBhvr>
                                         <p:cTn id="128" dur="900"/>
                                         <p:tgtEl>
-                                          <p:spTgt spid="30"/>
+                                          <p:spTgt spid="32"/>
                                         </p:tgtEl>
                                       </p:cBhvr>
                                     </p:animEffect>
@@ -6328,7 +6328,7 @@
                                           </p:stCondLst>
                                         </p:cTn>
                                         <p:tgtEl>
-                                          <p:spTgt spid="23"/>
+                                          <p:spTgt spid="21"/>
                                         </p:tgtEl>
                                         <p:attrNameLst>
                                           <p:attrName>style.visibility</p:attrName>
@@ -6342,7 +6342,7 @@
                                       <p:cBhvr>
                                         <p:cTn id="133" dur="900" fill="hold"/>
                                         <p:tgtEl>
-                                          <p:spTgt spid="23"/>
+                                          <p:spTgt spid="21"/>
                                         </p:tgtEl>
                                         <p:attrNameLst>
                                           <p:attrName>ppt_w</p:attrName>
@@ -6365,7 +6365,7 @@
                                       <p:cBhvr>
                                         <p:cTn id="134" dur="900" fill="hold"/>
                                         <p:tgtEl>
-                                          <p:spTgt spid="23"/>
+                                          <p:spTgt spid="21"/>
                                         </p:tgtEl>
                                         <p:attrNameLst>
                                           <p:attrName>ppt_h</p:attrName>
@@ -6388,7 +6388,7 @@
                                       <p:cBhvr>
                                         <p:cTn id="135" dur="900"/>
                                         <p:tgtEl>
-                                          <p:spTgt spid="23"/>
+                                          <p:spTgt spid="21"/>
                                         </p:tgtEl>
                                       </p:cBhvr>
                                     </p:animEffect>
@@ -6427,7 +6427,7 @@
                                           </p:stCondLst>
                                         </p:cTn>
                                         <p:tgtEl>
-                                          <p:spTgt spid="35"/>
+                                          <p:spTgt spid="33"/>
                                         </p:tgtEl>
                                         <p:attrNameLst>
                                           <p:attrName>style.visibility</p:attrName>
@@ -6441,7 +6441,7 @@
                                       <p:cBhvr>
                                         <p:cTn id="140" dur="900" fill="hold"/>
                                         <p:tgtEl>
-                                          <p:spTgt spid="35"/>
+                                          <p:spTgt spid="33"/>
                                         </p:tgtEl>
                                         <p:attrNameLst>
                                           <p:attrName>ppt_w</p:attrName>
@@ -6464,7 +6464,7 @@
                                       <p:cBhvr>
                                         <p:cTn id="141" dur="900" fill="hold"/>
                                         <p:tgtEl>
-                                          <p:spTgt spid="35"/>
+                                          <p:spTgt spid="33"/>
                                         </p:tgtEl>
                                         <p:attrNameLst>
                                           <p:attrName>ppt_h</p:attrName>
@@ -6487,7 +6487,7 @@
                                       <p:cBhvr>
                                         <p:cTn id="142" dur="900"/>
                                         <p:tgtEl>
-                                          <p:spTgt spid="35"/>
+                                          <p:spTgt spid="33"/>
                                         </p:tgtEl>
                                       </p:cBhvr>
                                     </p:animEffect>
@@ -6724,7 +6724,7 @@
                                           </p:stCondLst>
                                         </p:cTn>
                                         <p:tgtEl>
-                                          <p:spTgt spid="21"/>
+                                          <p:spTgt spid="23"/>
                                         </p:tgtEl>
                                         <p:attrNameLst>
                                           <p:attrName>style.visibility</p:attrName>
@@ -6738,7 +6738,7 @@
                                       <p:cBhvr>
                                         <p:cTn id="161" dur="900" fill="hold"/>
                                         <p:tgtEl>
-                                          <p:spTgt spid="21"/>
+                                          <p:spTgt spid="23"/>
                                         </p:tgtEl>
                                         <p:attrNameLst>
                                           <p:attrName>ppt_w</p:attrName>
@@ -6761,7 +6761,7 @@
                                       <p:cBhvr>
                                         <p:cTn id="162" dur="900" fill="hold"/>
                                         <p:tgtEl>
-                                          <p:spTgt spid="21"/>
+                                          <p:spTgt spid="23"/>
                                         </p:tgtEl>
                                         <p:attrNameLst>
                                           <p:attrName>ppt_h</p:attrName>
@@ -6784,7 +6784,7 @@
                                       <p:cBhvr>
                                         <p:cTn id="163" dur="900"/>
                                         <p:tgtEl>
-                                          <p:spTgt spid="21"/>
+                                          <p:spTgt spid="23"/>
                                         </p:tgtEl>
                                       </p:cBhvr>
                                     </p:animEffect>
@@ -6823,7 +6823,7 @@
                                           </p:stCondLst>
                                         </p:cTn>
                                         <p:tgtEl>
-                                          <p:spTgt spid="33"/>
+                                          <p:spTgt spid="35"/>
                                         </p:tgtEl>
                                         <p:attrNameLst>
                                           <p:attrName>style.visibility</p:attrName>
@@ -6837,7 +6837,7 @@
                                       <p:cBhvr>
                                         <p:cTn id="168" dur="900" fill="hold"/>
                                         <p:tgtEl>
-                                          <p:spTgt spid="33"/>
+                                          <p:spTgt spid="35"/>
                                         </p:tgtEl>
                                         <p:attrNameLst>
                                           <p:attrName>ppt_w</p:attrName>
@@ -6860,7 +6860,7 @@
                                       <p:cBhvr>
                                         <p:cTn id="169" dur="900" fill="hold"/>
                                         <p:tgtEl>
-                                          <p:spTgt spid="33"/>
+                                          <p:spTgt spid="35"/>
                                         </p:tgtEl>
                                         <p:attrNameLst>
                                           <p:attrName>ppt_h</p:attrName>
@@ -6883,7 +6883,7 @@
                                       <p:cBhvr>
                                         <p:cTn id="170" dur="900"/>
                                         <p:tgtEl>
-                                          <p:spTgt spid="33"/>
+                                          <p:spTgt spid="35"/>
                                         </p:tgtEl>
                                       </p:cBhvr>
                                     </p:animEffect>

</xml_diff>